<commit_message>
Chem-feed deck: HVN balance as two single-chart slides (all PADDs + one extra PADD 3)
Undo the side-by-side. The renamed HVN balance stays one full-width chart (all
PADDs); add ONE extra slide with the same chart filtered to PADD 3 (Gulf). The
model already splits them out (HVN sheet: all-PADD block + PADD-3 block), unchanged.

Co-Authored-By: Claude Opus 4.8 <noreply@anthropic.com>
Claude-Session: https://claude.ai/code/session_015p5NLGbwXS8USzMXyom8VW
</commit_message>
<xml_diff>
--- a/output/outage_deck_naphtha.pptx
+++ b/output/outage_deck_naphtha.pptx
@@ -13,6 +13,7 @@
     <p:sldId id="261" r:id="rId12"/>
     <p:sldId id="262" r:id="rId13"/>
     <p:sldId id="263" r:id="rId14"/>
+    <p:sldId id="264" r:id="rId15"/>
   </p:sldIdLst>
   <p:sldSz cx="12191695" cy="6858000" type="screen4x3"/>
   <p:notesSz cx="6858000" cy="9144000"/>
@@ -4102,7 +4103,7 @@
                 </a:solidFill>
                 <a:latin typeface="Arial"/>
               </a:rPr>
-              <a:t>Heavy virgin naphtha (the reformer feed) across 2026-2027. Left = all PADDs; right = PADD 3 (Gulf) only</a:t>
+              <a:t>Heavy virgin naphtha (the reformer feed) across 2026-2027. CDU makes it; reformers consume it</a:t>
             </a:r>
           </a:p>
         </p:txBody>
@@ -4201,41 +4202,17 @@
         </p:blipFill>
         <p:spPr>
           <a:xfrm>
-            <a:off x="365760" y="2296506"/>
-            <a:ext cx="5632704" cy="2447868"/>
+            <a:off x="820526" y="1188720"/>
+            <a:ext cx="10520468" cy="4572000"/>
           </a:xfrm>
           <a:prstGeom prst="rect">
             <a:avLst/>
           </a:prstGeom>
         </p:spPr>
       </p:pic>
-      <p:pic>
-        <p:nvPicPr>
-          <p:cNvPr id="7" name="Picture 6" descr="naphtha_forward_p3.png"/>
-          <p:cNvPicPr>
-            <a:picLocks noChangeAspect="1"/>
-          </p:cNvPicPr>
-          <p:nvPr/>
-        </p:nvPicPr>
-        <p:blipFill>
-          <a:blip r:embed="rId3"/>
-          <a:stretch>
-            <a:fillRect/>
-          </a:stretch>
-        </p:blipFill>
-        <p:spPr>
-          <a:xfrm>
-            <a:off x="6190488" y="2296506"/>
-            <a:ext cx="5632704" cy="2447868"/>
-          </a:xfrm>
-          <a:prstGeom prst="rect">
-            <a:avLst/>
-          </a:prstGeom>
-        </p:spPr>
-      </p:pic>
-      <p:sp>
-        <p:nvSpPr>
-          <p:cNvPr id="8" name="TextBox 7"/>
+      <p:sp>
+        <p:nvSpPr>
+          <p:cNvPr id="7" name="TextBox 6"/>
           <p:cNvSpPr txBox="1"/>
           <p:nvPr/>
         </p:nvSpPr>
@@ -4267,7 +4244,7 @@
                 </a:solidFill>
                 <a:latin typeface="Arial"/>
               </a:rPr>
-              <a:t>Net = reformer offline (HVN demand) minus CDU offline x 0.35 (HVN supply, ~35% of crude), day-weighted. The forward window runs short -- 15 of 18 months in deficit overall, 13 in PADD 3. The Gulf drives the HVN tightness.</a:t>
+              <a:t>Net = reformer offline (HVN demand) minus CDU offline x 0.35 (HVN supply, ~35% of crude), day-weighted. The forward window runs short (15 of 18 months in deficit): crude turnarounds pull more HVN off than reformers free.</a:t>
             </a:r>
           </a:p>
         </p:txBody>
@@ -4324,7 +4301,7 @@
                 </a:solidFill>
                 <a:latin typeface="Arial"/>
               </a:rPr>
-              <a:t>Naphtha / Octane / Chem-Feed Complex</a:t>
+              <a:t>HVN Balance: PADD 3 (Gulf) Only</a:t>
             </a:r>
           </a:p>
         </p:txBody>
@@ -4363,7 +4340,7 @@
                 </a:solidFill>
                 <a:latin typeface="Arial"/>
               </a:rPr>
-              <a:t>Reforming, isomerization and aromatics/BTX offline by year - the octane &amp; petrochem-feed read</a:t>
+              <a:t>The same HVN balance, CDU &amp; reformers filtered to PADD 3 (Gulf) -- where the tightness sits</a:t>
             </a:r>
           </a:p>
         </p:txBody>
@@ -4448,7 +4425,7 @@
       </p:sp>
       <p:pic>
         <p:nvPicPr>
-          <p:cNvPr id="6" name="Picture 5" descr="naphtha_complex.png"/>
+          <p:cNvPr id="6" name="Picture 5" descr="naphtha_forward_p3.png"/>
           <p:cNvPicPr>
             <a:picLocks noChangeAspect="1"/>
           </p:cNvPicPr>
@@ -4462,8 +4439,8 @@
         </p:blipFill>
         <p:spPr>
           <a:xfrm>
-            <a:off x="771038" y="1188720"/>
-            <a:ext cx="10619443" cy="4572000"/>
+            <a:off x="820526" y="1188720"/>
+            <a:ext cx="10520468" cy="4572000"/>
           </a:xfrm>
           <a:prstGeom prst="rect">
             <a:avLst/>
@@ -4504,7 +4481,7 @@
                 </a:solidFill>
                 <a:latin typeface="Arial"/>
               </a:rPr>
-              <a:t>The naphtha/octane complex (reformer charge + steam-cracker / petrochem feed). Offline ~1,562 kbd in 2026 and ~832 kbd booked in 2027. Reforming dominates; this is the octane/chem-feed availability a CDU-only tracker misses.</a:t>
+              <a:t>PADD 3 (Gulf) only -- the same supply/demand read as the prior slide, just the Gulf cut. 13 of 18 forward months in deficit; the Gulf carries ~66% of the 2027 HVN deficit.</a:t>
             </a:r>
           </a:p>
         </p:txBody>
@@ -4561,7 +4538,7 @@
                 </a:solidFill>
                 <a:latin typeface="Arial"/>
               </a:rPr>
-              <a:t>What's Driving It: Biggest 2026 &amp; 2027 Outages</a:t>
+              <a:t>Naphtha / Octane / Chem-Feed Complex</a:t>
             </a:r>
           </a:p>
         </p:txBody>
@@ -4600,7 +4577,7 @@
                 </a:solidFill>
                 <a:latin typeface="Arial"/>
               </a:rPr>
-              <a:t>Biggest individual focus-unit outages, 2026 (left) and 2027 (right), by PADD</a:t>
+              <a:t>Reforming, isomerization and aromatics/BTX offline by year - the octane &amp; petrochem-feed read</a:t>
             </a:r>
           </a:p>
         </p:txBody>
@@ -4685,7 +4662,7 @@
       </p:sp>
       <p:pic>
         <p:nvPicPr>
-          <p:cNvPr id="6" name="Picture 5" descr="biggest_cy.png"/>
+          <p:cNvPr id="6" name="Picture 5" descr="naphtha_complex.png"/>
           <p:cNvPicPr>
             <a:picLocks noChangeAspect="1"/>
           </p:cNvPicPr>
@@ -4699,41 +4676,17 @@
         </p:blipFill>
         <p:spPr>
           <a:xfrm>
-            <a:off x="365760" y="1626139"/>
-            <a:ext cx="5632704" cy="3788601"/>
+            <a:off x="771038" y="1188720"/>
+            <a:ext cx="10619443" cy="4572000"/>
           </a:xfrm>
           <a:prstGeom prst="rect">
             <a:avLst/>
           </a:prstGeom>
         </p:spPr>
       </p:pic>
-      <p:pic>
-        <p:nvPicPr>
-          <p:cNvPr id="7" name="Picture 6" descr="biggest_fy.png"/>
-          <p:cNvPicPr>
-            <a:picLocks noChangeAspect="1"/>
-          </p:cNvPicPr>
-          <p:nvPr/>
-        </p:nvPicPr>
-        <p:blipFill>
-          <a:blip r:embed="rId3"/>
-          <a:stretch>
-            <a:fillRect/>
-          </a:stretch>
-        </p:blipFill>
-        <p:spPr>
-          <a:xfrm>
-            <a:off x="6190488" y="1585188"/>
-            <a:ext cx="5632704" cy="3870503"/>
-          </a:xfrm>
-          <a:prstGeom prst="rect">
-            <a:avLst/>
-          </a:prstGeom>
-        </p:spPr>
-      </p:pic>
-      <p:sp>
-        <p:nvSpPr>
-          <p:cNvPr id="8" name="TextBox 7"/>
+      <p:sp>
+        <p:nvSpPr>
+          <p:cNvPr id="7" name="TextBox 6"/>
           <p:cNvSpPr txBox="1"/>
           <p:nvPr/>
         </p:nvSpPr>
@@ -4765,7 +4718,7 @@
                 </a:solidFill>
                 <a:latin typeface="Arial"/>
               </a:rPr>
-              <a:t>Per-unit nameplate offline (never summed), the biggest outages each year. Color = PADD region. 2027 non-Exxon H2 is still being booked (an indicative floor).</a:t>
+              <a:t>The naphtha/octane complex (reformer charge + steam-cracker / petrochem feed). Offline ~1,562 kbd in 2026 and ~832 kbd booked in 2027. Reforming dominates; this is the octane/chem-feed availability a CDU-only tracker misses.</a:t>
             </a:r>
           </a:p>
         </p:txBody>
@@ -4822,7 +4775,7 @@
                 </a:solidFill>
                 <a:latin typeface="Arial"/>
               </a:rPr>
-              <a:t>Reformer Outages by PADD</a:t>
+              <a:t>What's Driving It: Biggest 2026 &amp; 2027 Outages</a:t>
             </a:r>
           </a:p>
         </p:txBody>
@@ -4861,7 +4814,7 @@
                 </a:solidFill>
                 <a:latin typeface="Arial"/>
               </a:rPr>
-              <a:t>Reformer (octane) offline by region &amp; month: 2026 (left) vs 2027 (right)</a:t>
+              <a:t>Biggest individual focus-unit outages, 2026 (left) and 2027 (right), by PADD</a:t>
             </a:r>
           </a:p>
         </p:txBody>
@@ -4946,7 +4899,7 @@
       </p:sp>
       <p:pic>
         <p:nvPicPr>
-          <p:cNvPr id="6" name="Picture 5" descr="ref_padd_cy.png"/>
+          <p:cNvPr id="6" name="Picture 5" descr="biggest_cy.png"/>
           <p:cNvPicPr>
             <a:picLocks noChangeAspect="1"/>
           </p:cNvPicPr>
@@ -4960,8 +4913,8 @@
         </p:blipFill>
         <p:spPr>
           <a:xfrm>
-            <a:off x="365760" y="1985654"/>
-            <a:ext cx="5632704" cy="3069572"/>
+            <a:off x="365760" y="1626139"/>
+            <a:ext cx="5632704" cy="3788601"/>
           </a:xfrm>
           <a:prstGeom prst="rect">
             <a:avLst/>
@@ -4970,7 +4923,7 @@
       </p:pic>
       <p:pic>
         <p:nvPicPr>
-          <p:cNvPr id="7" name="Picture 6" descr="ref_padd_fy.png"/>
+          <p:cNvPr id="7" name="Picture 6" descr="biggest_fy.png"/>
           <p:cNvPicPr>
             <a:picLocks noChangeAspect="1"/>
           </p:cNvPicPr>
@@ -4984,8 +4937,8 @@
         </p:blipFill>
         <p:spPr>
           <a:xfrm>
-            <a:off x="6190488" y="1985654"/>
-            <a:ext cx="5632704" cy="3069572"/>
+            <a:off x="6190488" y="1585188"/>
+            <a:ext cx="5632704" cy="3870503"/>
           </a:xfrm>
           <a:prstGeom prst="rect">
             <a:avLst/>
@@ -5026,7 +4979,7 @@
                 </a:solidFill>
                 <a:latin typeface="Arial"/>
               </a:rPr>
-              <a:t>Day-weighted concurrent reformer offline by month, stacked by PADD. P1 NE, P2 Midwest, P3 Gulf, P4 Rockies, P5 West. P3 (Gulf) carries the bulk of the octane loss.</a:t>
+              <a:t>Per-unit nameplate offline (never summed), the biggest outages each year. Color = PADD region. 2027 non-Exxon H2 is still being booked (an indicative floor).</a:t>
             </a:r>
           </a:p>
         </p:txBody>
@@ -5083,7 +5036,7 @@
                 </a:solidFill>
                 <a:latin typeface="Arial"/>
               </a:rPr>
-              <a:t>Unplanned Offline: 2024-2026 Context</a:t>
+              <a:t>Reformer Outages by PADD</a:t>
             </a:r>
           </a:p>
         </p:txBody>
@@ -5122,7 +5075,7 @@
                 </a:solidFill>
                 <a:latin typeface="Arial"/>
               </a:rPr>
-              <a:t>What unplanned actually looked like recently, to ground the forward window</a:t>
+              <a:t>Reformer (octane) offline by region &amp; month: 2026 (left) vs 2027 (right)</a:t>
             </a:r>
           </a:p>
         </p:txBody>
@@ -5201,6 +5154,267 @@
                 <a:latin typeface="Arial"/>
               </a:rPr>
               <a:t>7</a:t>
+            </a:r>
+          </a:p>
+        </p:txBody>
+      </p:sp>
+      <p:pic>
+        <p:nvPicPr>
+          <p:cNvPr id="6" name="Picture 5" descr="ref_padd_cy.png"/>
+          <p:cNvPicPr>
+            <a:picLocks noChangeAspect="1"/>
+          </p:cNvPicPr>
+          <p:nvPr/>
+        </p:nvPicPr>
+        <p:blipFill>
+          <a:blip r:embed="rId2"/>
+          <a:stretch>
+            <a:fillRect/>
+          </a:stretch>
+        </p:blipFill>
+        <p:spPr>
+          <a:xfrm>
+            <a:off x="365760" y="1985654"/>
+            <a:ext cx="5632704" cy="3069572"/>
+          </a:xfrm>
+          <a:prstGeom prst="rect">
+            <a:avLst/>
+          </a:prstGeom>
+        </p:spPr>
+      </p:pic>
+      <p:pic>
+        <p:nvPicPr>
+          <p:cNvPr id="7" name="Picture 6" descr="ref_padd_fy.png"/>
+          <p:cNvPicPr>
+            <a:picLocks noChangeAspect="1"/>
+          </p:cNvPicPr>
+          <p:nvPr/>
+        </p:nvPicPr>
+        <p:blipFill>
+          <a:blip r:embed="rId3"/>
+          <a:stretch>
+            <a:fillRect/>
+          </a:stretch>
+        </p:blipFill>
+        <p:spPr>
+          <a:xfrm>
+            <a:off x="6190488" y="1985654"/>
+            <a:ext cx="5632704" cy="3069572"/>
+          </a:xfrm>
+          <a:prstGeom prst="rect">
+            <a:avLst/>
+          </a:prstGeom>
+        </p:spPr>
+      </p:pic>
+      <p:sp>
+        <p:nvSpPr>
+          <p:cNvPr id="8" name="TextBox 7"/>
+          <p:cNvSpPr txBox="1"/>
+          <p:nvPr/>
+        </p:nvSpPr>
+        <p:spPr>
+          <a:xfrm>
+            <a:off x="457200" y="5888736"/>
+            <a:ext cx="11247120" cy="566928"/>
+          </a:xfrm>
+          <a:prstGeom prst="rect">
+            <a:avLst/>
+          </a:prstGeom>
+          <a:noFill/>
+        </p:spPr>
+        <p:txBody>
+          <a:bodyPr wrap="square" anchor="t" lIns="12700" rIns="12700" tIns="12700" bIns="12700">
+            <a:spAutoFit/>
+          </a:bodyPr>
+          <a:lstStyle/>
+          <a:p>
+            <a:pPr algn="l">
+              <a:spcAft>
+                <a:spcPts val="300"/>
+              </a:spcAft>
+            </a:pPr>
+            <a:r>
+              <a:rPr sz="800" b="0" i="1">
+                <a:solidFill>
+                  <a:srgbClr val="595959"/>
+                </a:solidFill>
+                <a:latin typeface="Arial"/>
+              </a:rPr>
+              <a:t>Day-weighted concurrent reformer offline by month, stacked by PADD. P1 NE, P2 Midwest, P3 Gulf, P4 Rockies, P5 West. P3 (Gulf) carries the bulk of the octane loss.</a:t>
+            </a:r>
+          </a:p>
+        </p:txBody>
+      </p:sp>
+    </p:spTree>
+  </p:cSld>
+  <p:clrMapOvr>
+    <a:masterClrMapping/>
+  </p:clrMapOvr>
+</p:sld>
+</file>
+
+<file path=ppt/slides/slide9.xml><?xml version="1.0" encoding="utf-8"?>
+<p:sld xmlns:a="http://schemas.openxmlformats.org/drawingml/2006/main" xmlns:p="http://schemas.openxmlformats.org/presentationml/2006/main" xmlns:r="http://schemas.openxmlformats.org/officeDocument/2006/relationships">
+  <p:cSld>
+    <p:spTree>
+      <p:nvGrpSpPr>
+        <p:cNvPr id="1" name=""/>
+        <p:cNvGrpSpPr/>
+        <p:nvPr/>
+      </p:nvGrpSpPr>
+      <p:grpSpPr/>
+      <p:sp>
+        <p:nvSpPr>
+          <p:cNvPr id="2" name="TextBox 1"/>
+          <p:cNvSpPr txBox="1"/>
+          <p:nvPr/>
+        </p:nvSpPr>
+        <p:spPr>
+          <a:xfrm>
+            <a:off x="411480" y="164592"/>
+            <a:ext cx="11338560" cy="640080"/>
+          </a:xfrm>
+          <a:prstGeom prst="rect">
+            <a:avLst/>
+          </a:prstGeom>
+          <a:noFill/>
+        </p:spPr>
+        <p:txBody>
+          <a:bodyPr wrap="square" anchor="ctr" lIns="12700" rIns="12700" tIns="12700" bIns="12700">
+            <a:spAutoFit/>
+          </a:bodyPr>
+          <a:lstStyle/>
+          <a:p>
+            <a:pPr algn="l">
+              <a:spcAft>
+                <a:spcPts val="300"/>
+              </a:spcAft>
+            </a:pPr>
+            <a:r>
+              <a:rPr sz="3000" b="0" i="0">
+                <a:solidFill>
+                  <a:srgbClr val="C00000"/>
+                </a:solidFill>
+                <a:latin typeface="Arial"/>
+              </a:rPr>
+              <a:t>Unplanned Offline: 2024-2026 Context</a:t>
+            </a:r>
+          </a:p>
+        </p:txBody>
+      </p:sp>
+      <p:sp>
+        <p:nvSpPr>
+          <p:cNvPr id="3" name="TextBox 2"/>
+          <p:cNvSpPr txBox="1"/>
+          <p:nvPr/>
+        </p:nvSpPr>
+        <p:spPr>
+          <a:xfrm>
+            <a:off x="457200" y="841248"/>
+            <a:ext cx="11247120" cy="274320"/>
+          </a:xfrm>
+          <a:prstGeom prst="rect">
+            <a:avLst/>
+          </a:prstGeom>
+          <a:noFill/>
+        </p:spPr>
+        <p:txBody>
+          <a:bodyPr wrap="square" anchor="t" lIns="12700" rIns="12700" tIns="12700" bIns="12700">
+            <a:spAutoFit/>
+          </a:bodyPr>
+          <a:lstStyle/>
+          <a:p>
+            <a:pPr algn="l">
+              <a:spcAft>
+                <a:spcPts val="300"/>
+              </a:spcAft>
+            </a:pPr>
+            <a:r>
+              <a:rPr sz="1200" b="0" i="0">
+                <a:solidFill>
+                  <a:srgbClr val="595959"/>
+                </a:solidFill>
+                <a:latin typeface="Arial"/>
+              </a:rPr>
+              <a:t>What unplanned actually looked like recently, to ground the forward window</a:t>
+            </a:r>
+          </a:p>
+        </p:txBody>
+      </p:sp>
+      <p:sp>
+        <p:nvSpPr>
+          <p:cNvPr id="4" name="TextBox 3"/>
+          <p:cNvSpPr txBox="1"/>
+          <p:nvPr/>
+        </p:nvSpPr>
+        <p:spPr>
+          <a:xfrm>
+            <a:off x="411480" y="6537960"/>
+            <a:ext cx="2743200" cy="292608"/>
+          </a:xfrm>
+          <a:prstGeom prst="rect">
+            <a:avLst/>
+          </a:prstGeom>
+          <a:noFill/>
+        </p:spPr>
+        <p:txBody>
+          <a:bodyPr wrap="square" anchor="ctr" lIns="12700" rIns="12700" tIns="12700" bIns="12700">
+            <a:spAutoFit/>
+          </a:bodyPr>
+          <a:lstStyle/>
+          <a:p>
+            <a:pPr algn="l">
+              <a:spcAft>
+                <a:spcPts val="300"/>
+              </a:spcAft>
+            </a:pPr>
+            <a:r>
+              <a:rPr sz="1300" b="1" i="0">
+                <a:solidFill>
+                  <a:srgbClr val="C00000"/>
+                </a:solidFill>
+                <a:latin typeface="Arial"/>
+              </a:rPr>
+              <a:t>Products Trading</a:t>
+            </a:r>
+          </a:p>
+        </p:txBody>
+      </p:sp>
+      <p:sp>
+        <p:nvSpPr>
+          <p:cNvPr id="5" name="TextBox 4"/>
+          <p:cNvSpPr txBox="1"/>
+          <p:nvPr/>
+        </p:nvSpPr>
+        <p:spPr>
+          <a:xfrm>
+            <a:off x="11430000" y="6547104"/>
+            <a:ext cx="640080" cy="274320"/>
+          </a:xfrm>
+          <a:prstGeom prst="rect">
+            <a:avLst/>
+          </a:prstGeom>
+          <a:noFill/>
+        </p:spPr>
+        <p:txBody>
+          <a:bodyPr wrap="square" anchor="t" lIns="12700" rIns="12700" tIns="12700" bIns="12700">
+            <a:spAutoFit/>
+          </a:bodyPr>
+          <a:lstStyle/>
+          <a:p>
+            <a:pPr algn="r">
+              <a:spcAft>
+                <a:spcPts val="300"/>
+              </a:spcAft>
+            </a:pPr>
+            <a:r>
+              <a:rPr sz="900" b="0" i="0">
+                <a:solidFill>
+                  <a:srgbClr val="595959"/>
+                </a:solidFill>
+                <a:latin typeface="Arial"/>
+              </a:rPr>
+              <a:t>8</a:t>
             </a:r>
           </a:p>
         </p:txBody>

</xml_diff>

<commit_message>
Chem-feed deck: trim to the 7 slides asked for, balance slides at 3-4
Final chem-feed set: title, outages by unit (2026 vs 2027), HVN balance (all US),
HVN balance PADD 3 (Gulf), reformers/octane read, naphtha-octane-chem-feed
complex, what's driving it. Dropped reformer-by-PADD and unplanned-context;
moved the two HVN balance slides ahead of the octane read. Model unchanged.

Co-Authored-By: Claude Opus 4.8 <noreply@anthropic.com>
Claude-Session: https://claude.ai/code/session_015p5NLGbwXS8USzMXyom8VW
</commit_message>
<xml_diff>
--- a/output/outage_deck_naphtha.pptx
+++ b/output/outage_deck_naphtha.pptx
@@ -12,8 +12,6 @@
     <p:sldId id="260" r:id="rId11"/>
     <p:sldId id="261" r:id="rId12"/>
     <p:sldId id="262" r:id="rId13"/>
-    <p:sldId id="263" r:id="rId14"/>
-    <p:sldId id="264" r:id="rId15"/>
   </p:sldIdLst>
   <p:sldSz cx="12191695" cy="6858000" type="screen4x3"/>
   <p:notesSz cx="6858000" cy="9144000"/>
@@ -3827,7 +3825,7 @@
                 </a:solidFill>
                 <a:latin typeface="Arial"/>
               </a:rPr>
-              <a:t>Reformers: the Octane Read</a:t>
+              <a:t>HVN Balance: CDU Supply vs Reformer Demand</a:t>
             </a:r>
           </a:p>
         </p:txBody>
@@ -3866,7 +3864,7 @@
                 </a:solidFill>
                 <a:latin typeface="Arial"/>
               </a:rPr>
-              <a:t>Catalytic-reformer offline by month &amp; PADD across 2026-2027, with reformate (octane) lost</a:t>
+              <a:t>Heavy virgin naphtha (the reformer feed) across 2026-2027. CDU makes it; reformers consume it</a:t>
             </a:r>
           </a:p>
         </p:txBody>
@@ -3951,7 +3949,7 @@
       </p:sp>
       <p:pic>
         <p:nvPicPr>
-          <p:cNvPr id="6" name="Picture 5" descr="reformer_forward.png"/>
+          <p:cNvPr id="6" name="Picture 5" descr="naphtha_forward.png"/>
           <p:cNvPicPr>
             <a:picLocks noChangeAspect="1"/>
           </p:cNvPicPr>
@@ -4007,7 +4005,7 @@
                 </a:solidFill>
                 <a:latin typeface="Arial"/>
               </a:rPr>
-              <a:t>Reformers run naphtha -&gt; reformate (the octane in gasoline). Over the forward window (rest of 2026 + 2027), ~1,227 kbd of reformer offline = ~1,043 kbd of reformate (octane) not made. P3 (Gulf) carries the most.</a:t>
+              <a:t>Net = reformer offline (HVN demand) minus CDU offline x 0.35 (HVN supply, ~35% of crude), day-weighted. The forward window runs short (15 of 18 months in deficit): crude turnarounds pull more HVN off than reformers free.</a:t>
             </a:r>
           </a:p>
         </p:txBody>
@@ -4064,7 +4062,7 @@
                 </a:solidFill>
                 <a:latin typeface="Arial"/>
               </a:rPr>
-              <a:t>HVN Balance: CDU Supply vs Reformer Demand</a:t>
+              <a:t>HVN Balance: PADD 3 (Gulf) Only</a:t>
             </a:r>
           </a:p>
         </p:txBody>
@@ -4103,7 +4101,7 @@
                 </a:solidFill>
                 <a:latin typeface="Arial"/>
               </a:rPr>
-              <a:t>Heavy virgin naphtha (the reformer feed) across 2026-2027. CDU makes it; reformers consume it</a:t>
+              <a:t>The same HVN balance, CDU &amp; reformers filtered to PADD 3 (Gulf) -- where the tightness sits</a:t>
             </a:r>
           </a:p>
         </p:txBody>
@@ -4188,7 +4186,7 @@
       </p:sp>
       <p:pic>
         <p:nvPicPr>
-          <p:cNvPr id="6" name="Picture 5" descr="naphtha_forward.png"/>
+          <p:cNvPr id="6" name="Picture 5" descr="naphtha_forward_p3.png"/>
           <p:cNvPicPr>
             <a:picLocks noChangeAspect="1"/>
           </p:cNvPicPr>
@@ -4244,7 +4242,7 @@
                 </a:solidFill>
                 <a:latin typeface="Arial"/>
               </a:rPr>
-              <a:t>Net = reformer offline (HVN demand) minus CDU offline x 0.35 (HVN supply, ~35% of crude), day-weighted. The forward window runs short (15 of 18 months in deficit): crude turnarounds pull more HVN off than reformers free.</a:t>
+              <a:t>PADD 3 (Gulf) only -- the same supply/demand read as the prior slide, just the Gulf cut. 13 of 18 forward months in deficit; the Gulf carries ~66% of the 2027 HVN deficit.</a:t>
             </a:r>
           </a:p>
         </p:txBody>
@@ -4301,7 +4299,7 @@
                 </a:solidFill>
                 <a:latin typeface="Arial"/>
               </a:rPr>
-              <a:t>HVN Balance: PADD 3 (Gulf) Only</a:t>
+              <a:t>Reformers: the Octane Read</a:t>
             </a:r>
           </a:p>
         </p:txBody>
@@ -4340,7 +4338,7 @@
                 </a:solidFill>
                 <a:latin typeface="Arial"/>
               </a:rPr>
-              <a:t>The same HVN balance, CDU &amp; reformers filtered to PADD 3 (Gulf) -- where the tightness sits</a:t>
+              <a:t>Catalytic-reformer offline by month &amp; PADD across 2026-2027, with reformate (octane) lost</a:t>
             </a:r>
           </a:p>
         </p:txBody>
@@ -4425,7 +4423,7 @@
       </p:sp>
       <p:pic>
         <p:nvPicPr>
-          <p:cNvPr id="6" name="Picture 5" descr="naphtha_forward_p3.png"/>
+          <p:cNvPr id="6" name="Picture 5" descr="reformer_forward.png"/>
           <p:cNvPicPr>
             <a:picLocks noChangeAspect="1"/>
           </p:cNvPicPr>
@@ -4481,7 +4479,7 @@
                 </a:solidFill>
                 <a:latin typeface="Arial"/>
               </a:rPr>
-              <a:t>PADD 3 (Gulf) only -- the same supply/demand read as the prior slide, just the Gulf cut. 13 of 18 forward months in deficit; the Gulf carries ~66% of the 2027 HVN deficit.</a:t>
+              <a:t>Reformers run naphtha -&gt; reformate (the octane in gasoline). Over the forward window (rest of 2026 + 2027), ~1,227 kbd of reformer offline = ~1,043 kbd of reformate (octane) not made. P3 (Gulf) carries the most.</a:t>
             </a:r>
           </a:p>
         </p:txBody>
@@ -4980,504 +4978,6 @@
                 <a:latin typeface="Arial"/>
               </a:rPr>
               <a:t>Per-unit nameplate offline (never summed), the biggest outages each year. Color = PADD region. 2027 non-Exxon H2 is still being booked (an indicative floor).</a:t>
-            </a:r>
-          </a:p>
-        </p:txBody>
-      </p:sp>
-    </p:spTree>
-  </p:cSld>
-  <p:clrMapOvr>
-    <a:masterClrMapping/>
-  </p:clrMapOvr>
-</p:sld>
-</file>
-
-<file path=ppt/slides/slide8.xml><?xml version="1.0" encoding="utf-8"?>
-<p:sld xmlns:a="http://schemas.openxmlformats.org/drawingml/2006/main" xmlns:p="http://schemas.openxmlformats.org/presentationml/2006/main" xmlns:r="http://schemas.openxmlformats.org/officeDocument/2006/relationships">
-  <p:cSld>
-    <p:spTree>
-      <p:nvGrpSpPr>
-        <p:cNvPr id="1" name=""/>
-        <p:cNvGrpSpPr/>
-        <p:nvPr/>
-      </p:nvGrpSpPr>
-      <p:grpSpPr/>
-      <p:sp>
-        <p:nvSpPr>
-          <p:cNvPr id="2" name="TextBox 1"/>
-          <p:cNvSpPr txBox="1"/>
-          <p:nvPr/>
-        </p:nvSpPr>
-        <p:spPr>
-          <a:xfrm>
-            <a:off x="411480" y="164592"/>
-            <a:ext cx="11338560" cy="640080"/>
-          </a:xfrm>
-          <a:prstGeom prst="rect">
-            <a:avLst/>
-          </a:prstGeom>
-          <a:noFill/>
-        </p:spPr>
-        <p:txBody>
-          <a:bodyPr wrap="square" anchor="ctr" lIns="12700" rIns="12700" tIns="12700" bIns="12700">
-            <a:spAutoFit/>
-          </a:bodyPr>
-          <a:lstStyle/>
-          <a:p>
-            <a:pPr algn="l">
-              <a:spcAft>
-                <a:spcPts val="300"/>
-              </a:spcAft>
-            </a:pPr>
-            <a:r>
-              <a:rPr sz="3000" b="0" i="0">
-                <a:solidFill>
-                  <a:srgbClr val="C00000"/>
-                </a:solidFill>
-                <a:latin typeface="Arial"/>
-              </a:rPr>
-              <a:t>Reformer Outages by PADD</a:t>
-            </a:r>
-          </a:p>
-        </p:txBody>
-      </p:sp>
-      <p:sp>
-        <p:nvSpPr>
-          <p:cNvPr id="3" name="TextBox 2"/>
-          <p:cNvSpPr txBox="1"/>
-          <p:nvPr/>
-        </p:nvSpPr>
-        <p:spPr>
-          <a:xfrm>
-            <a:off x="457200" y="841248"/>
-            <a:ext cx="11247120" cy="274320"/>
-          </a:xfrm>
-          <a:prstGeom prst="rect">
-            <a:avLst/>
-          </a:prstGeom>
-          <a:noFill/>
-        </p:spPr>
-        <p:txBody>
-          <a:bodyPr wrap="square" anchor="t" lIns="12700" rIns="12700" tIns="12700" bIns="12700">
-            <a:spAutoFit/>
-          </a:bodyPr>
-          <a:lstStyle/>
-          <a:p>
-            <a:pPr algn="l">
-              <a:spcAft>
-                <a:spcPts val="300"/>
-              </a:spcAft>
-            </a:pPr>
-            <a:r>
-              <a:rPr sz="1200" b="0" i="0">
-                <a:solidFill>
-                  <a:srgbClr val="595959"/>
-                </a:solidFill>
-                <a:latin typeface="Arial"/>
-              </a:rPr>
-              <a:t>Reformer (octane) offline by region &amp; month: 2026 (left) vs 2027 (right)</a:t>
-            </a:r>
-          </a:p>
-        </p:txBody>
-      </p:sp>
-      <p:sp>
-        <p:nvSpPr>
-          <p:cNvPr id="4" name="TextBox 3"/>
-          <p:cNvSpPr txBox="1"/>
-          <p:nvPr/>
-        </p:nvSpPr>
-        <p:spPr>
-          <a:xfrm>
-            <a:off x="411480" y="6537960"/>
-            <a:ext cx="2743200" cy="292608"/>
-          </a:xfrm>
-          <a:prstGeom prst="rect">
-            <a:avLst/>
-          </a:prstGeom>
-          <a:noFill/>
-        </p:spPr>
-        <p:txBody>
-          <a:bodyPr wrap="square" anchor="ctr" lIns="12700" rIns="12700" tIns="12700" bIns="12700">
-            <a:spAutoFit/>
-          </a:bodyPr>
-          <a:lstStyle/>
-          <a:p>
-            <a:pPr algn="l">
-              <a:spcAft>
-                <a:spcPts val="300"/>
-              </a:spcAft>
-            </a:pPr>
-            <a:r>
-              <a:rPr sz="1300" b="1" i="0">
-                <a:solidFill>
-                  <a:srgbClr val="C00000"/>
-                </a:solidFill>
-                <a:latin typeface="Arial"/>
-              </a:rPr>
-              <a:t>Products Trading</a:t>
-            </a:r>
-          </a:p>
-        </p:txBody>
-      </p:sp>
-      <p:sp>
-        <p:nvSpPr>
-          <p:cNvPr id="5" name="TextBox 4"/>
-          <p:cNvSpPr txBox="1"/>
-          <p:nvPr/>
-        </p:nvSpPr>
-        <p:spPr>
-          <a:xfrm>
-            <a:off x="11430000" y="6547104"/>
-            <a:ext cx="640080" cy="274320"/>
-          </a:xfrm>
-          <a:prstGeom prst="rect">
-            <a:avLst/>
-          </a:prstGeom>
-          <a:noFill/>
-        </p:spPr>
-        <p:txBody>
-          <a:bodyPr wrap="square" anchor="t" lIns="12700" rIns="12700" tIns="12700" bIns="12700">
-            <a:spAutoFit/>
-          </a:bodyPr>
-          <a:lstStyle/>
-          <a:p>
-            <a:pPr algn="r">
-              <a:spcAft>
-                <a:spcPts val="300"/>
-              </a:spcAft>
-            </a:pPr>
-            <a:r>
-              <a:rPr sz="900" b="0" i="0">
-                <a:solidFill>
-                  <a:srgbClr val="595959"/>
-                </a:solidFill>
-                <a:latin typeface="Arial"/>
-              </a:rPr>
-              <a:t>7</a:t>
-            </a:r>
-          </a:p>
-        </p:txBody>
-      </p:sp>
-      <p:pic>
-        <p:nvPicPr>
-          <p:cNvPr id="6" name="Picture 5" descr="ref_padd_cy.png"/>
-          <p:cNvPicPr>
-            <a:picLocks noChangeAspect="1"/>
-          </p:cNvPicPr>
-          <p:nvPr/>
-        </p:nvPicPr>
-        <p:blipFill>
-          <a:blip r:embed="rId2"/>
-          <a:stretch>
-            <a:fillRect/>
-          </a:stretch>
-        </p:blipFill>
-        <p:spPr>
-          <a:xfrm>
-            <a:off x="365760" y="1985654"/>
-            <a:ext cx="5632704" cy="3069572"/>
-          </a:xfrm>
-          <a:prstGeom prst="rect">
-            <a:avLst/>
-          </a:prstGeom>
-        </p:spPr>
-      </p:pic>
-      <p:pic>
-        <p:nvPicPr>
-          <p:cNvPr id="7" name="Picture 6" descr="ref_padd_fy.png"/>
-          <p:cNvPicPr>
-            <a:picLocks noChangeAspect="1"/>
-          </p:cNvPicPr>
-          <p:nvPr/>
-        </p:nvPicPr>
-        <p:blipFill>
-          <a:blip r:embed="rId3"/>
-          <a:stretch>
-            <a:fillRect/>
-          </a:stretch>
-        </p:blipFill>
-        <p:spPr>
-          <a:xfrm>
-            <a:off x="6190488" y="1985654"/>
-            <a:ext cx="5632704" cy="3069572"/>
-          </a:xfrm>
-          <a:prstGeom prst="rect">
-            <a:avLst/>
-          </a:prstGeom>
-        </p:spPr>
-      </p:pic>
-      <p:sp>
-        <p:nvSpPr>
-          <p:cNvPr id="8" name="TextBox 7"/>
-          <p:cNvSpPr txBox="1"/>
-          <p:nvPr/>
-        </p:nvSpPr>
-        <p:spPr>
-          <a:xfrm>
-            <a:off x="457200" y="5888736"/>
-            <a:ext cx="11247120" cy="566928"/>
-          </a:xfrm>
-          <a:prstGeom prst="rect">
-            <a:avLst/>
-          </a:prstGeom>
-          <a:noFill/>
-        </p:spPr>
-        <p:txBody>
-          <a:bodyPr wrap="square" anchor="t" lIns="12700" rIns="12700" tIns="12700" bIns="12700">
-            <a:spAutoFit/>
-          </a:bodyPr>
-          <a:lstStyle/>
-          <a:p>
-            <a:pPr algn="l">
-              <a:spcAft>
-                <a:spcPts val="300"/>
-              </a:spcAft>
-            </a:pPr>
-            <a:r>
-              <a:rPr sz="800" b="0" i="1">
-                <a:solidFill>
-                  <a:srgbClr val="595959"/>
-                </a:solidFill>
-                <a:latin typeface="Arial"/>
-              </a:rPr>
-              <a:t>Day-weighted concurrent reformer offline by month, stacked by PADD. P1 NE, P2 Midwest, P3 Gulf, P4 Rockies, P5 West. P3 (Gulf) carries the bulk of the octane loss.</a:t>
-            </a:r>
-          </a:p>
-        </p:txBody>
-      </p:sp>
-    </p:spTree>
-  </p:cSld>
-  <p:clrMapOvr>
-    <a:masterClrMapping/>
-  </p:clrMapOvr>
-</p:sld>
-</file>
-
-<file path=ppt/slides/slide9.xml><?xml version="1.0" encoding="utf-8"?>
-<p:sld xmlns:a="http://schemas.openxmlformats.org/drawingml/2006/main" xmlns:p="http://schemas.openxmlformats.org/presentationml/2006/main" xmlns:r="http://schemas.openxmlformats.org/officeDocument/2006/relationships">
-  <p:cSld>
-    <p:spTree>
-      <p:nvGrpSpPr>
-        <p:cNvPr id="1" name=""/>
-        <p:cNvGrpSpPr/>
-        <p:nvPr/>
-      </p:nvGrpSpPr>
-      <p:grpSpPr/>
-      <p:sp>
-        <p:nvSpPr>
-          <p:cNvPr id="2" name="TextBox 1"/>
-          <p:cNvSpPr txBox="1"/>
-          <p:nvPr/>
-        </p:nvSpPr>
-        <p:spPr>
-          <a:xfrm>
-            <a:off x="411480" y="164592"/>
-            <a:ext cx="11338560" cy="640080"/>
-          </a:xfrm>
-          <a:prstGeom prst="rect">
-            <a:avLst/>
-          </a:prstGeom>
-          <a:noFill/>
-        </p:spPr>
-        <p:txBody>
-          <a:bodyPr wrap="square" anchor="ctr" lIns="12700" rIns="12700" tIns="12700" bIns="12700">
-            <a:spAutoFit/>
-          </a:bodyPr>
-          <a:lstStyle/>
-          <a:p>
-            <a:pPr algn="l">
-              <a:spcAft>
-                <a:spcPts val="300"/>
-              </a:spcAft>
-            </a:pPr>
-            <a:r>
-              <a:rPr sz="3000" b="0" i="0">
-                <a:solidFill>
-                  <a:srgbClr val="C00000"/>
-                </a:solidFill>
-                <a:latin typeface="Arial"/>
-              </a:rPr>
-              <a:t>Unplanned Offline: 2024-2026 Context</a:t>
-            </a:r>
-          </a:p>
-        </p:txBody>
-      </p:sp>
-      <p:sp>
-        <p:nvSpPr>
-          <p:cNvPr id="3" name="TextBox 2"/>
-          <p:cNvSpPr txBox="1"/>
-          <p:nvPr/>
-        </p:nvSpPr>
-        <p:spPr>
-          <a:xfrm>
-            <a:off x="457200" y="841248"/>
-            <a:ext cx="11247120" cy="274320"/>
-          </a:xfrm>
-          <a:prstGeom prst="rect">
-            <a:avLst/>
-          </a:prstGeom>
-          <a:noFill/>
-        </p:spPr>
-        <p:txBody>
-          <a:bodyPr wrap="square" anchor="t" lIns="12700" rIns="12700" tIns="12700" bIns="12700">
-            <a:spAutoFit/>
-          </a:bodyPr>
-          <a:lstStyle/>
-          <a:p>
-            <a:pPr algn="l">
-              <a:spcAft>
-                <a:spcPts val="300"/>
-              </a:spcAft>
-            </a:pPr>
-            <a:r>
-              <a:rPr sz="1200" b="0" i="0">
-                <a:solidFill>
-                  <a:srgbClr val="595959"/>
-                </a:solidFill>
-                <a:latin typeface="Arial"/>
-              </a:rPr>
-              <a:t>What unplanned actually looked like recently, to ground the forward window</a:t>
-            </a:r>
-          </a:p>
-        </p:txBody>
-      </p:sp>
-      <p:sp>
-        <p:nvSpPr>
-          <p:cNvPr id="4" name="TextBox 3"/>
-          <p:cNvSpPr txBox="1"/>
-          <p:nvPr/>
-        </p:nvSpPr>
-        <p:spPr>
-          <a:xfrm>
-            <a:off x="411480" y="6537960"/>
-            <a:ext cx="2743200" cy="292608"/>
-          </a:xfrm>
-          <a:prstGeom prst="rect">
-            <a:avLst/>
-          </a:prstGeom>
-          <a:noFill/>
-        </p:spPr>
-        <p:txBody>
-          <a:bodyPr wrap="square" anchor="ctr" lIns="12700" rIns="12700" tIns="12700" bIns="12700">
-            <a:spAutoFit/>
-          </a:bodyPr>
-          <a:lstStyle/>
-          <a:p>
-            <a:pPr algn="l">
-              <a:spcAft>
-                <a:spcPts val="300"/>
-              </a:spcAft>
-            </a:pPr>
-            <a:r>
-              <a:rPr sz="1300" b="1" i="0">
-                <a:solidFill>
-                  <a:srgbClr val="C00000"/>
-                </a:solidFill>
-                <a:latin typeface="Arial"/>
-              </a:rPr>
-              <a:t>Products Trading</a:t>
-            </a:r>
-          </a:p>
-        </p:txBody>
-      </p:sp>
-      <p:sp>
-        <p:nvSpPr>
-          <p:cNvPr id="5" name="TextBox 4"/>
-          <p:cNvSpPr txBox="1"/>
-          <p:nvPr/>
-        </p:nvSpPr>
-        <p:spPr>
-          <a:xfrm>
-            <a:off x="11430000" y="6547104"/>
-            <a:ext cx="640080" cy="274320"/>
-          </a:xfrm>
-          <a:prstGeom prst="rect">
-            <a:avLst/>
-          </a:prstGeom>
-          <a:noFill/>
-        </p:spPr>
-        <p:txBody>
-          <a:bodyPr wrap="square" anchor="t" lIns="12700" rIns="12700" tIns="12700" bIns="12700">
-            <a:spAutoFit/>
-          </a:bodyPr>
-          <a:lstStyle/>
-          <a:p>
-            <a:pPr algn="r">
-              <a:spcAft>
-                <a:spcPts val="300"/>
-              </a:spcAft>
-            </a:pPr>
-            <a:r>
-              <a:rPr sz="900" b="0" i="0">
-                <a:solidFill>
-                  <a:srgbClr val="595959"/>
-                </a:solidFill>
-                <a:latin typeface="Arial"/>
-              </a:rPr>
-              <a:t>8</a:t>
-            </a:r>
-          </a:p>
-        </p:txBody>
-      </p:sp>
-      <p:pic>
-        <p:nvPicPr>
-          <p:cNvPr id="6" name="Picture 5" descr="unplanned_context.png"/>
-          <p:cNvPicPr>
-            <a:picLocks noChangeAspect="1"/>
-          </p:cNvPicPr>
-          <p:nvPr/>
-        </p:nvPicPr>
-        <p:blipFill>
-          <a:blip r:embed="rId2"/>
-          <a:stretch>
-            <a:fillRect/>
-          </a:stretch>
-        </p:blipFill>
-        <p:spPr>
-          <a:xfrm>
-            <a:off x="1311891" y="1188720"/>
-            <a:ext cx="9537738" cy="4572000"/>
-          </a:xfrm>
-          <a:prstGeom prst="rect">
-            <a:avLst/>
-          </a:prstGeom>
-        </p:spPr>
-      </p:pic>
-      <p:sp>
-        <p:nvSpPr>
-          <p:cNvPr id="7" name="TextBox 6"/>
-          <p:cNvSpPr txBox="1"/>
-          <p:nvPr/>
-        </p:nvSpPr>
-        <p:spPr>
-          <a:xfrm>
-            <a:off x="457200" y="5888736"/>
-            <a:ext cx="11247120" cy="566928"/>
-          </a:xfrm>
-          <a:prstGeom prst="rect">
-            <a:avLst/>
-          </a:prstGeom>
-          <a:noFill/>
-        </p:spPr>
-        <p:txBody>
-          <a:bodyPr wrap="square" anchor="t" lIns="12700" rIns="12700" tIns="12700" bIns="12700">
-            <a:spAutoFit/>
-          </a:bodyPr>
-          <a:lstStyle/>
-          <a:p>
-            <a:pPr algn="l">
-              <a:spcAft>
-                <a:spcPts val="300"/>
-              </a:spcAft>
-            </a:pPr>
-            <a:r>
-              <a:rPr sz="800" b="0" i="1">
-                <a:solidFill>
-                  <a:srgbClr val="595959"/>
-                </a:solidFill>
-                <a:latin typeface="Arial"/>
-              </a:rPr>
-              <a:t>Actual unplanned capacity offline by month, day-weighted. 2026 reported through June; the Feb-freeze and autumn-turnaround windows are the recurring risk to carry forward.</a:t>
             </a:r>
           </a:p>
         </p:txBody>

</xml_diff>